<commit_message>
docs(workshop): align the deck with the corrected defaults
The workshop deck still taught the pre-alignment model. Update both deck
sources — the iA Presenter markdown and the pptxgenjs generator — and
regenerate the .pptx:

- XML-RPC: granular per-category toggles + multicall server swap, not the
  blunt xmlrpc_enabled=false.
- Application Passwords: available by default (the safer credential), not
  disabled.
- Strong passwords: 15+ chars + breach screening (NIST/OWASP), not 12-char
  forced composition.
- Title-only admin search: post_search_columns, not a posts_search rewrite.
- Login logo: defaults to keep_default; any change links home (the separate
  link toggle is gone).
- Opening framing + cheat sheet updated to match.

Also fix build_deck.js's output path (was a foreign /home/claude path) so
the .pptx builds reproducibly in-repo.

Better-by-Default.pdf still needs re-export from iA Presenter (GUI-only) —
the one deck artifact that can't be regenerated headlessly.
</commit_message>
<xml_diff>
--- a/workshop/Better-by-Default.pptx
+++ b/workshop/Better-by-Default.pptx
@@ -617,7 +617,7 @@
           <a:p>
             <a:r>
               <a:rPr lang="en-US" dirty="0"/>
-              <a:t>Never trust the client. The JS meter is UX; the server-side rule is enforcement. 12 chars + mixed classes is a reasonable floor.</a:t>
+              <a:t>Never trust the client — the JS meter is UX, the server rule is the wall. Length + breach screening is the modern NIST/OWASP guidance; composition rules are out.</a:t>
             </a:r>
             <a:endParaRPr lang="en-US" dirty="0"/>
           </a:p>
@@ -1321,7 +1321,7 @@
           <a:p>
             <a:r>
               <a:rPr lang="en-US" dirty="0"/>
-              <a:t>Note the is_admin() guard — we scope the search change so we never touch the visitor-facing search. Scoping filters correctly is the craft here.</a:t>
+              <a:t>post_search_columns (WP 6.2+) narrows the columns instead of rewriting the SQL clause — it keeps core's term parsing and the logged-out password guard intact. Scoping filters correctly is the craft here.</a:t>
             </a:r>
             <a:endParaRPr lang="en-US" dirty="0"/>
           </a:p>
@@ -1673,7 +1673,7 @@
           <a:p>
             <a:r>
               <a:rPr lang="en-US" dirty="0"/>
-              <a:t>Swap display:none for a background-image to drop in the client's own logo. Tiny detail clients always notice.</a:t>
+              <a:t>Default is keep_default — leave the login screen untouched. Swap in a background-image to drop in the client's own logo. Tiny detail clients always notice.</a:t>
             </a:r>
             <a:endParaRPr lang="en-US" dirty="0"/>
           </a:p>
@@ -2817,7 +2817,7 @@
           <a:p>
             <a:r>
               <a:rPr lang="en-US" dirty="0"/>
-              <a:t>Check with the client before disabling if they use the WordPress mobile app or older Jetpack features over XML-RPC. Most sites don't.</a:t>
+              <a:t>system.multicall can't be removed by the xmlrpc_methods filter — IXR re-adds it — so we swap in a server that refuses it. Don't *block the endpoint* on a Jetpack site: that breaks its WordPress.com connection; the method toggles leave jetpack.* alone.</a:t>
             </a:r>
             <a:endParaRPr lang="en-US" dirty="0"/>
           </a:p>
@@ -2905,7 +2905,7 @@
           <a:p>
             <a:r>
               <a:rPr lang="en-US" dirty="0"/>
-              <a:t>One-liner. The only caveat: if the site talks to an external app via REST auth, leave the feature on.</a:t>
+              <a:t>Turning them off just pushes people to worse habits like sharing the login password. They stay available by default — the safer, revocable REST credential.</a:t>
             </a:r>
             <a:endParaRPr lang="en-US" dirty="0"/>
           </a:p>
@@ -3676,7 +3676,7 @@
                 <a:ea typeface="Calibri" pitchFamily="34" charset="-122"/>
                 <a:cs typeface="Calibri" pitchFamily="34" charset="-120"/>
               </a:rPr>
-              <a:t>Core shows a strength meter but never enforces it — a determined user can still save “password1”. We validate server-side on profile save and password reset, turning the warning into a wall.</a:t>
+              <a:t>NIST 800-63B and OWASP now say length plus breach screening beats composition rules. Forcing upper/lower/number/symbol just herds users to Password1! — predictable, not strong. We require 15+ chars and screen against known breaches, server-side.</a:t>
             </a:r>
             <a:endParaRPr lang="en-US" sz="1600" dirty="0"/>
           </a:p>
@@ -3898,13 +3898,13 @@
             <a:r>
               <a:rPr lang="en-US" sz="1150" dirty="0">
                 <a:solidFill>
-                  <a:srgbClr val="DCEAF1"/>
+                  <a:srgbClr val="E7C070"/>
                 </a:solidFill>
                 <a:latin typeface="Courier New" pitchFamily="34" charset="0"/>
                 <a:ea typeface="Courier New" pitchFamily="34" charset="-122"/>
                 <a:cs typeface="Courier New" pitchFamily="34" charset="-120"/>
               </a:rPr>
-              <a:t>$ok = strlen( $pw ) &gt;= 12</a:t>
+              <a:t>if ( strlen( $pw ) &lt; 15 ) {</a:t>
             </a:r>
             <a:endParaRPr lang="en-US" sz="1150" dirty="0"/>
           </a:p>
@@ -3918,13 +3918,13 @@
             <a:r>
               <a:rPr lang="en-US" sz="1150" dirty="0">
                 <a:solidFill>
-                  <a:srgbClr val="E7C070"/>
+                  <a:srgbClr val="DCEAF1"/>
                 </a:solidFill>
                 <a:latin typeface="Courier New" pitchFamily="34" charset="0"/>
                 <a:ea typeface="Courier New" pitchFamily="34" charset="-122"/>
                 <a:cs typeface="Courier New" pitchFamily="34" charset="-120"/>
               </a:rPr>
-              <a:t>   &amp;&amp; preg_match( '/[A-Z]/', $pw )</a:t>
+              <a:t>    $errors-&gt;add( 'short', 'Use 15+ chars.' );</a:t>
             </a:r>
             <a:endParaRPr lang="en-US" sz="1150" dirty="0"/>
           </a:p>
@@ -3938,13 +3938,13 @@
             <a:r>
               <a:rPr lang="en-US" sz="1150" dirty="0">
                 <a:solidFill>
-                  <a:srgbClr val="E7C070"/>
+                  <a:srgbClr val="DCEAF1"/>
                 </a:solidFill>
                 <a:latin typeface="Courier New" pitchFamily="34" charset="0"/>
                 <a:ea typeface="Courier New" pitchFamily="34" charset="-122"/>
                 <a:cs typeface="Courier New" pitchFamily="34" charset="-120"/>
               </a:rPr>
-              <a:t>   &amp;&amp; preg_match( '/[a-z]/', $pw )</a:t>
+              <a:t>}</a:t>
             </a:r>
             <a:endParaRPr lang="en-US" sz="1150" dirty="0"/>
           </a:p>
@@ -3958,13 +3958,13 @@
             <a:r>
               <a:rPr lang="en-US" sz="1150" dirty="0">
                 <a:solidFill>
-                  <a:srgbClr val="E7C070"/>
+                  <a:srgbClr val="DCEAF1"/>
                 </a:solidFill>
                 <a:latin typeface="Courier New" pitchFamily="34" charset="0"/>
                 <a:ea typeface="Courier New" pitchFamily="34" charset="-122"/>
                 <a:cs typeface="Courier New" pitchFamily="34" charset="-120"/>
               </a:rPr>
-              <a:t>   &amp;&amp; preg_match( '/[0-9]/', $pw )</a:t>
+              <a:t> </a:t>
             </a:r>
             <a:endParaRPr lang="en-US" sz="1150" dirty="0"/>
           </a:p>
@@ -3978,13 +3978,13 @@
             <a:r>
               <a:rPr lang="en-US" sz="1150" dirty="0">
                 <a:solidFill>
-                  <a:srgbClr val="E7C070"/>
+                  <a:srgbClr val="8FBF9F"/>
                 </a:solidFill>
                 <a:latin typeface="Courier New" pitchFamily="34" charset="0"/>
                 <a:ea typeface="Courier New" pitchFamily="34" charset="-122"/>
                 <a:cs typeface="Courier New" pitchFamily="34" charset="-120"/>
               </a:rPr>
-              <a:t>   &amp;&amp; preg_match( '/[^A-Za-z0-9]/', $pw );</a:t>
+              <a:t>// screen against breaches (HIBP),</a:t>
             </a:r>
             <a:endParaRPr lang="en-US" sz="1150" dirty="0"/>
           </a:p>
@@ -3998,13 +3998,13 @@
             <a:r>
               <a:rPr lang="en-US" sz="1150" dirty="0">
                 <a:solidFill>
-                  <a:srgbClr val="DCEAF1"/>
+                  <a:srgbClr val="8FBF9F"/>
                 </a:solidFill>
                 <a:latin typeface="Courier New" pitchFamily="34" charset="0"/>
                 <a:ea typeface="Courier New" pitchFamily="34" charset="-122"/>
                 <a:cs typeface="Courier New" pitchFamily="34" charset="-120"/>
               </a:rPr>
-              <a:t> </a:t>
+              <a:t>// not composition rules</a:t>
             </a:r>
             <a:endParaRPr lang="en-US" sz="1150" dirty="0"/>
           </a:p>
@@ -4018,13 +4018,13 @@
             <a:r>
               <a:rPr lang="en-US" sz="1150" dirty="0">
                 <a:solidFill>
-                  <a:srgbClr val="DCEAF1"/>
+                  <a:srgbClr val="E7C070"/>
                 </a:solidFill>
                 <a:latin typeface="Courier New" pitchFamily="34" charset="0"/>
                 <a:ea typeface="Courier New" pitchFamily="34" charset="-122"/>
                 <a:cs typeface="Courier New" pitchFamily="34" charset="-120"/>
               </a:rPr>
-              <a:t>if ( ! $ok ) {</a:t>
+              <a:t>if ( wpyeg_password_is_pwned( $pw ) ) {</a:t>
             </a:r>
             <a:endParaRPr lang="en-US" sz="1150" dirty="0"/>
           </a:p>
@@ -4044,7 +4044,7 @@
                 <a:ea typeface="Courier New" pitchFamily="34" charset="-122"/>
                 <a:cs typeface="Courier New" pitchFamily="34" charset="-120"/>
               </a:rPr>
-              <a:t>    $errors-&gt;add( 'weak', 'Too weak.' );</a:t>
+              <a:t>    $errors-&gt;add( 'pwned', 'Seen in a breach.' );</a:t>
             </a:r>
             <a:endParaRPr lang="en-US" sz="1150" dirty="0"/>
           </a:p>
@@ -8066,7 +8066,7 @@
                 <a:ea typeface="Courier New" pitchFamily="34" charset="-122"/>
                 <a:cs typeface="Courier New" pitchFamily="34" charset="-120"/>
               </a:rPr>
-              <a:t>// title-only admin search (scoped!)</a:t>
+              <a:t>// title-only admin search — narrow the COLUMNS</a:t>
             </a:r>
             <a:endParaRPr lang="en-US" sz="1100" dirty="0"/>
           </a:p>
@@ -8086,7 +8086,7 @@
                 <a:ea typeface="Courier New" pitchFamily="34" charset="-122"/>
                 <a:cs typeface="Courier New" pitchFamily="34" charset="-120"/>
               </a:rPr>
-              <a:t>add_filter( 'posts_search', function ( $sql, $q ) {</a:t>
+              <a:t>add_filter( 'post_search_columns',</a:t>
             </a:r>
             <a:endParaRPr lang="en-US" sz="1100" dirty="0"/>
           </a:p>
@@ -8106,7 +8106,7 @@
                 <a:ea typeface="Courier New" pitchFamily="34" charset="-122"/>
                 <a:cs typeface="Courier New" pitchFamily="34" charset="-120"/>
               </a:rPr>
-              <a:t>  if ( ! is_admin() || ! $q-&gt;is_main_query() )</a:t>
+              <a:t>  function ( $cols, $s, $q ) {</a:t>
             </a:r>
             <a:endParaRPr lang="en-US" sz="1100" dirty="0"/>
           </a:p>
@@ -8120,13 +8120,13 @@
             <a:r>
               <a:rPr lang="en-US" sz="1100" dirty="0">
                 <a:solidFill>
-                  <a:srgbClr val="E7C070"/>
+                  <a:srgbClr val="DCEAF1"/>
                 </a:solidFill>
                 <a:latin typeface="Courier New" pitchFamily="34" charset="0"/>
                 <a:ea typeface="Courier New" pitchFamily="34" charset="-122"/>
                 <a:cs typeface="Courier New" pitchFamily="34" charset="-120"/>
               </a:rPr>
-              <a:t>      return $sql;   // front-end untouched</a:t>
+              <a:t>    if ( is_admin() &amp;&amp; $q-&gt;is_main_query() )</a:t>
             </a:r>
             <a:endParaRPr lang="en-US" sz="1100" dirty="0"/>
           </a:p>
@@ -8140,13 +8140,13 @@
             <a:r>
               <a:rPr lang="en-US" sz="1100" dirty="0">
                 <a:solidFill>
-                  <a:srgbClr val="8FBF9F"/>
+                  <a:srgbClr val="E7C070"/>
                 </a:solidFill>
                 <a:latin typeface="Courier New" pitchFamily="34" charset="0"/>
                 <a:ea typeface="Courier New" pitchFamily="34" charset="-122"/>
                 <a:cs typeface="Courier New" pitchFamily="34" charset="-120"/>
               </a:rPr>
-              <a:t>  // ...match post_title only</a:t>
+              <a:t>        return array( 'post_title' );</a:t>
             </a:r>
             <a:endParaRPr lang="en-US" sz="1100" dirty="0"/>
           </a:p>
@@ -8166,7 +8166,7 @@
                 <a:ea typeface="Courier New" pitchFamily="34" charset="-122"/>
                 <a:cs typeface="Courier New" pitchFamily="34" charset="-120"/>
               </a:rPr>
-              <a:t>}, 10, 2 );</a:t>
+              <a:t>    return $cols;   // front-end untouched</a:t>
             </a:r>
             <a:endParaRPr lang="en-US" sz="1100" dirty="0"/>
           </a:p>
@@ -8186,7 +8186,7 @@
                 <a:ea typeface="Courier New" pitchFamily="34" charset="-122"/>
                 <a:cs typeface="Courier New" pitchFamily="34" charset="-120"/>
               </a:rPr>
-              <a:t> </a:t>
+              <a:t>  }, 10, 3 );</a:t>
             </a:r>
             <a:endParaRPr lang="en-US" sz="1100" dirty="0"/>
           </a:p>
@@ -9363,7 +9363,7 @@
                 <a:ea typeface="Cambria" pitchFamily="34" charset="-122"/>
                 <a:cs typeface="Cambria" pitchFamily="34" charset="-120"/>
               </a:rPr>
-              <a:t>Legacy endpoints open</a:t>
+              <a:t>Legacy XML-RPC wide open</a:t>
             </a:r>
             <a:endParaRPr lang="en-US" sz="1900" dirty="0"/>
           </a:p>
@@ -9402,7 +9402,7 @@
                 <a:ea typeface="Calibri" pitchFamily="34" charset="-122"/>
                 <a:cs typeface="Calibri" pitchFamily="34" charset="-120"/>
               </a:rPr>
-              <a:t>XML-RPC and Application Passwords stay on — classic brute-force amplifiers.</a:t>
+              <a:t>pingback and system.multicall amplifiers answer by default.</a:t>
             </a:r>
             <a:endParaRPr lang="en-US" sz="1400" dirty="0"/>
           </a:p>
@@ -10233,7 +10233,7 @@
                 <a:ea typeface="Calibri" pitchFamily="34" charset="-122"/>
                 <a:cs typeface="Calibri" pitchFamily="34" charset="-120"/>
               </a:rPr>
-              <a:t>The default WordPress “W” on wp-login.php links out to wordpress.org — a subtle trust and brand leak on the one page where trust matters most. Remove or replace it, and point the link back home.</a:t>
+              <a:t>The default WordPress “W” on wp-login.php links out to wordpress.org — a subtle trust leak. But changing the login screen out of the box is intrusive, so the default is to leave it alone; removing, unlinking, or replacing the logo is an opt-in, and any change points the link home.</a:t>
             </a:r>
             <a:endParaRPr lang="en-US" sz="1600" dirty="0"/>
           </a:p>
@@ -10319,7 +10319,7 @@
                 <a:ea typeface="Courier New" pitchFamily="34" charset="-122"/>
                 <a:cs typeface="Courier New" pitchFamily="34" charset="-120"/>
               </a:rPr>
-              <a:t>wpyeg_login_logo_behavior / _login_logo_link_home</a:t>
+              <a:t>wpyeg_login_logo_behavior</a:t>
             </a:r>
             <a:pPr indent="0" marL="0">
               <a:lnSpc>
@@ -10365,7 +10365,7 @@
                 <a:ea typeface="Courier New" pitchFamily="34" charset="-122"/>
                 <a:cs typeface="Courier New" pitchFamily="34" charset="-120"/>
               </a:rPr>
-              <a:t>remove_logo / yes</a:t>
+              <a:t>keep_default (keep / remove / unlink / replace)</a:t>
             </a:r>
             <a:endParaRPr lang="en-US" sz="1150" dirty="0"/>
           </a:p>
@@ -10435,13 +10435,13 @@
             <a:r>
               <a:rPr lang="en-US" sz="1200" dirty="0">
                 <a:solidFill>
-                  <a:srgbClr val="DCEAF1"/>
+                  <a:srgbClr val="8FBF9F"/>
                 </a:solidFill>
                 <a:latin typeface="Courier New" pitchFamily="34" charset="0"/>
                 <a:ea typeface="Courier New" pitchFamily="34" charset="-122"/>
                 <a:cs typeface="Courier New" pitchFamily="34" charset="-120"/>
               </a:rPr>
-              <a:t>add_action( 'login_head', function () {</a:t>
+              <a:t>// remove, unlink, or replace — a choice</a:t>
             </a:r>
             <a:endParaRPr lang="en-US" sz="1200" dirty="0"/>
           </a:p>
@@ -10461,7 +10461,7 @@
                 <a:ea typeface="Courier New" pitchFamily="34" charset="-122"/>
                 <a:cs typeface="Courier New" pitchFamily="34" charset="-120"/>
               </a:rPr>
-              <a:t>  echo '&lt;style&gt;#login h1 a{display:none}&lt;/style&gt;';</a:t>
+              <a:t>add_action( 'login_head', $logo_css );</a:t>
             </a:r>
             <a:endParaRPr lang="en-US" sz="1200" dirty="0"/>
           </a:p>
@@ -10481,7 +10481,7 @@
                 <a:ea typeface="Courier New" pitchFamily="34" charset="-122"/>
                 <a:cs typeface="Courier New" pitchFamily="34" charset="-120"/>
               </a:rPr>
-              <a:t>} );</a:t>
+              <a:t> </a:t>
             </a:r>
             <a:endParaRPr lang="en-US" sz="1200" dirty="0"/>
           </a:p>
@@ -10495,13 +10495,33 @@
             <a:r>
               <a:rPr lang="en-US" sz="1200" dirty="0">
                 <a:solidFill>
-                  <a:srgbClr val="DCEAF1"/>
+                  <a:srgbClr val="8FBF9F"/>
                 </a:solidFill>
                 <a:latin typeface="Courier New" pitchFamily="34" charset="0"/>
                 <a:ea typeface="Courier New" pitchFamily="34" charset="-122"/>
                 <a:cs typeface="Courier New" pitchFamily="34" charset="-120"/>
               </a:rPr>
-              <a:t> </a:t>
+              <a:t>// any change points the link home</a:t>
+            </a:r>
+            <a:endParaRPr lang="en-US" sz="1200" dirty="0"/>
+          </a:p>
+          <a:p>
+            <a:pPr algn="l" indent="0" marL="0">
+              <a:lnSpc>
+                <a:spcPct val="108000"/>
+              </a:lnSpc>
+              <a:buNone/>
+            </a:pPr>
+            <a:r>
+              <a:rPr lang="en-US" sz="1200" dirty="0">
+                <a:solidFill>
+                  <a:srgbClr val="8FBF9F"/>
+                </a:solidFill>
+                <a:latin typeface="Courier New" pitchFamily="34" charset="0"/>
+                <a:ea typeface="Courier New" pitchFamily="34" charset="-122"/>
+                <a:cs typeface="Courier New" pitchFamily="34" charset="-120"/>
+              </a:rPr>
+              <a:t>// (no separate toggle)</a:t>
             </a:r>
             <a:endParaRPr lang="en-US" sz="1200" dirty="0"/>
           </a:p>
@@ -14845,7 +14865,7 @@
                           <a:ea typeface="Calibri" pitchFamily="34" charset="-122"/>
                           <a:cs typeface="Calibri" pitchFamily="34" charset="-120"/>
                         </a:rPr>
-                        <a:t>Disable XML-RPC</a:t>
+                        <a:t>Lock down XML-RPC by category</a:t>
                       </a:r>
                       <a:endParaRPr lang="en-US" sz="1250" dirty="0">
                         <a:latin typeface="Calibri" charset="0"/>
@@ -14913,7 +14933,7 @@
                           <a:ea typeface="Courier New" pitchFamily="34" charset="-122"/>
                           <a:cs typeface="Courier New" pitchFamily="34" charset="-120"/>
                         </a:rPr>
-                        <a:t>xmlrpc_enabled</a:t>
+                        <a:t>xmlrpc_methods / wp_xmlrpc_server_class</a:t>
                       </a:r>
                       <a:endParaRPr lang="en-US" sz="1100" dirty="0">
                         <a:latin typeface="Courier New" charset="0"/>
@@ -15051,7 +15071,7 @@
                           <a:ea typeface="Calibri" pitchFamily="34" charset="-122"/>
                           <a:cs typeface="Calibri" pitchFamily="34" charset="-120"/>
                         </a:rPr>
-                        <a:t>Disable Application Passwords</a:t>
+                        <a:t>Require strong passwords (15+ / breach-screened)</a:t>
                       </a:r>
                       <a:endParaRPr lang="en-US" sz="1250" dirty="0">
                         <a:latin typeface="Calibri" charset="0"/>
@@ -15119,7 +15139,7 @@
                           <a:ea typeface="Courier New" pitchFamily="34" charset="-122"/>
                           <a:cs typeface="Courier New" pitchFamily="34" charset="-120"/>
                         </a:rPr>
-                        <a:t>wp_is_application_passwords_available</a:t>
+                        <a:t>user_profile_update_errors</a:t>
                       </a:r>
                       <a:endParaRPr lang="en-US" sz="1100" dirty="0">
                         <a:latin typeface="Courier New" charset="0"/>
@@ -15257,7 +15277,7 @@
                           <a:ea typeface="Calibri" pitchFamily="34" charset="-122"/>
                           <a:cs typeface="Calibri" pitchFamily="34" charset="-120"/>
                         </a:rPr>
-                        <a:t>Require strong passwords</a:t>
+                        <a:t>Remove version + security headers</a:t>
                       </a:r>
                       <a:endParaRPr lang="en-US" sz="1250" dirty="0">
                         <a:latin typeface="Calibri" charset="0"/>
@@ -15325,7 +15345,7 @@
                           <a:ea typeface="Courier New" pitchFamily="34" charset="-122"/>
                           <a:cs typeface="Courier New" pitchFamily="34" charset="-120"/>
                         </a:rPr>
-                        <a:t>user_profile_update_errors</a:t>
+                        <a:t>wp_generator / wp_headers</a:t>
                       </a:r>
                       <a:endParaRPr lang="en-US" sz="1100" dirty="0">
                         <a:latin typeface="Courier New" charset="0"/>
@@ -15463,7 +15483,7 @@
                           <a:ea typeface="Calibri" pitchFamily="34" charset="-122"/>
                           <a:cs typeface="Calibri" pitchFamily="34" charset="-120"/>
                         </a:rPr>
-                        <a:t>Remove version + security headers</a:t>
+                        <a:t>Disable comments &amp; pingbacks</a:t>
                       </a:r>
                       <a:endParaRPr lang="en-US" sz="1250" dirty="0">
                         <a:latin typeface="Calibri" charset="0"/>
@@ -15531,7 +15551,7 @@
                           <a:ea typeface="Courier New" pitchFamily="34" charset="-122"/>
                           <a:cs typeface="Courier New" pitchFamily="34" charset="-120"/>
                         </a:rPr>
-                        <a:t>wp_generator / wp_headers</a:t>
+                        <a:t>comments_open / pings_open</a:t>
                       </a:r>
                       <a:endParaRPr lang="en-US" sz="1100" dirty="0">
                         <a:latin typeface="Courier New" charset="0"/>
@@ -15599,7 +15619,7 @@
                           <a:ea typeface="Calibri" pitchFamily="34" charset="-122"/>
                           <a:cs typeface="Calibri" pitchFamily="34" charset="-120"/>
                         </a:rPr>
-                        <a:t>Security</a:t>
+                        <a:t>Content</a:t>
                       </a:r>
                       <a:endParaRPr lang="en-US" sz="1200" dirty="0">
                         <a:latin typeface="Calibri" charset="0"/>
@@ -15669,7 +15689,7 @@
                           <a:ea typeface="Calibri" pitchFamily="34" charset="-122"/>
                           <a:cs typeface="Calibri" pitchFamily="34" charset="-120"/>
                         </a:rPr>
-                        <a:t>Disable comments &amp; pingbacks</a:t>
+                        <a:t>Redirect author + attachment pages</a:t>
                       </a:r>
                       <a:endParaRPr lang="en-US" sz="1250" dirty="0">
                         <a:latin typeface="Calibri" charset="0"/>
@@ -15737,7 +15757,7 @@
                           <a:ea typeface="Courier New" pitchFamily="34" charset="-122"/>
                           <a:cs typeface="Courier New" pitchFamily="34" charset="-120"/>
                         </a:rPr>
-                        <a:t>comments_open / pings_open</a:t>
+                        <a:t>template_redirect</a:t>
                       </a:r>
                       <a:endParaRPr lang="en-US" sz="1100" dirty="0">
                         <a:latin typeface="Courier New" charset="0"/>
@@ -15805,7 +15825,7 @@
                           <a:ea typeface="Calibri" pitchFamily="34" charset="-122"/>
                           <a:cs typeface="Calibri" pitchFamily="34" charset="-120"/>
                         </a:rPr>
-                        <a:t>Content</a:t>
+                        <a:t>Content / SEO</a:t>
                       </a:r>
                       <a:endParaRPr lang="en-US" sz="1200" dirty="0">
                         <a:latin typeface="Calibri" charset="0"/>
@@ -15875,7 +15895,7 @@
                           <a:ea typeface="Calibri" pitchFamily="34" charset="-122"/>
                           <a:cs typeface="Calibri" pitchFamily="34" charset="-120"/>
                         </a:rPr>
-                        <a:t>Redirect author + attachment pages</a:t>
+                        <a:t>Disable emoji script</a:t>
                       </a:r>
                       <a:endParaRPr lang="en-US" sz="1250" dirty="0">
                         <a:latin typeface="Calibri" charset="0"/>
@@ -15943,7 +15963,7 @@
                           <a:ea typeface="Courier New" pitchFamily="34" charset="-122"/>
                           <a:cs typeface="Courier New" pitchFamily="34" charset="-120"/>
                         </a:rPr>
-                        <a:t>template_redirect</a:t>
+                        <a:t>init (remove_action)</a:t>
                       </a:r>
                       <a:endParaRPr lang="en-US" sz="1100" dirty="0">
                         <a:latin typeface="Courier New" charset="0"/>
@@ -16011,419 +16031,7 @@
                           <a:ea typeface="Calibri" pitchFamily="34" charset="-122"/>
                           <a:cs typeface="Calibri" pitchFamily="34" charset="-120"/>
                         </a:rPr>
-                        <a:t>Content / SEO</a:t>
-                      </a:r>
-                      <a:endParaRPr lang="en-US" sz="1200" dirty="0">
-                        <a:latin typeface="Calibri" charset="0"/>
-                        <a:ea typeface="Calibri" charset="0"/>
-                        <a:cs typeface="Calibri" charset="0"/>
-                      </a:endParaRPr>
-                    </a:p>
-                  </a:txBody>
-                  <a:tcPr marL="50800" marR="50800" marT="50800" marB="50800" anchor="ctr">
-                    <a:lnL w="12700" cap="flat" cmpd="sng" algn="ctr">
-                      <a:solidFill>
-                        <a:srgbClr val="DCE6EB"/>
-                      </a:solidFill>
-                      <a:prstDash val="solid"/>
-                      <a:round/>
-                      <a:headEnd type="none" w="med" len="med"/>
-                      <a:tailEnd type="none" w="med" len="med"/>
-                    </a:lnL>
-                    <a:lnR w="12700" cap="flat" cmpd="sng" algn="ctr">
-                      <a:solidFill>
-                        <a:srgbClr val="DCE6EB"/>
-                      </a:solidFill>
-                      <a:prstDash val="solid"/>
-                      <a:round/>
-                      <a:headEnd type="none" w="med" len="med"/>
-                      <a:tailEnd type="none" w="med" len="med"/>
-                    </a:lnR>
-                    <a:lnT w="12700" cap="flat" cmpd="sng" algn="ctr">
-                      <a:solidFill>
-                        <a:srgbClr val="DCE6EB"/>
-                      </a:solidFill>
-                      <a:prstDash val="solid"/>
-                      <a:round/>
-                      <a:headEnd type="none" w="med" len="med"/>
-                      <a:tailEnd type="none" w="med" len="med"/>
-                    </a:lnT>
-                    <a:lnB w="12700" cap="flat" cmpd="sng" algn="ctr">
-                      <a:solidFill>
-                        <a:srgbClr val="DCE6EB"/>
-                      </a:solidFill>
-                      <a:prstDash val="solid"/>
-                      <a:round/>
-                      <a:headEnd type="none" w="med" len="med"/>
-                      <a:tailEnd type="none" w="med" len="med"/>
-                    </a:lnB>
-                    <a:solidFill>
-                      <a:srgbClr val="FFFFFF"/>
-                    </a:solidFill>
-                  </a:tcPr>
-                </a:tc>
-              </a:tr>
-              <a:tr h="402336">
-                <a:tc>
-                  <a:txBody>
-                    <a:bodyPr/>
-                    <a:lstStyle/>
-                    <a:p>
-                      <a:pPr algn="l" indent="0" marL="0">
-                        <a:buNone/>
-                      </a:pPr>
-                      <a:r>
-                        <a:rPr lang="en-US" sz="1250" dirty="0">
-                          <a:solidFill>
-                            <a:srgbClr val="0F2733"/>
-                          </a:solidFill>
-                          <a:latin typeface="Calibri" pitchFamily="34" charset="0"/>
-                          <a:ea typeface="Calibri" pitchFamily="34" charset="-122"/>
-                          <a:cs typeface="Calibri" pitchFamily="34" charset="-120"/>
-                        </a:rPr>
-                        <a:t>Disable emoji script</a:t>
-                      </a:r>
-                      <a:endParaRPr lang="en-US" sz="1250" dirty="0">
-                        <a:latin typeface="Calibri" charset="0"/>
-                        <a:ea typeface="Calibri" charset="0"/>
-                        <a:cs typeface="Calibri" charset="0"/>
-                      </a:endParaRPr>
-                    </a:p>
-                  </a:txBody>
-                  <a:tcPr marL="50800" marR="50800" marT="50800" marB="50800" anchor="ctr">
-                    <a:lnL w="12700" cap="flat" cmpd="sng" algn="ctr">
-                      <a:solidFill>
-                        <a:srgbClr val="DCE6EB"/>
-                      </a:solidFill>
-                      <a:prstDash val="solid"/>
-                      <a:round/>
-                      <a:headEnd type="none" w="med" len="med"/>
-                      <a:tailEnd type="none" w="med" len="med"/>
-                    </a:lnL>
-                    <a:lnR w="12700" cap="flat" cmpd="sng" algn="ctr">
-                      <a:solidFill>
-                        <a:srgbClr val="DCE6EB"/>
-                      </a:solidFill>
-                      <a:prstDash val="solid"/>
-                      <a:round/>
-                      <a:headEnd type="none" w="med" len="med"/>
-                      <a:tailEnd type="none" w="med" len="med"/>
-                    </a:lnR>
-                    <a:lnT w="12700" cap="flat" cmpd="sng" algn="ctr">
-                      <a:solidFill>
-                        <a:srgbClr val="DCE6EB"/>
-                      </a:solidFill>
-                      <a:prstDash val="solid"/>
-                      <a:round/>
-                      <a:headEnd type="none" w="med" len="med"/>
-                      <a:tailEnd type="none" w="med" len="med"/>
-                    </a:lnT>
-                    <a:lnB w="12700" cap="flat" cmpd="sng" algn="ctr">
-                      <a:solidFill>
-                        <a:srgbClr val="DCE6EB"/>
-                      </a:solidFill>
-                      <a:prstDash val="solid"/>
-                      <a:round/>
-                      <a:headEnd type="none" w="med" len="med"/>
-                      <a:tailEnd type="none" w="med" len="med"/>
-                    </a:lnB>
-                    <a:solidFill>
-                      <a:srgbClr val="EAF1F5"/>
-                    </a:solidFill>
-                  </a:tcPr>
-                </a:tc>
-                <a:tc>
-                  <a:txBody>
-                    <a:bodyPr/>
-                    <a:lstStyle/>
-                    <a:p>
-                      <a:pPr algn="l" indent="0" marL="0">
-                        <a:buNone/>
-                      </a:pPr>
-                      <a:r>
-                        <a:rPr lang="en-US" sz="1100" dirty="0">
-                          <a:solidFill>
-                            <a:srgbClr val="27607A"/>
-                          </a:solidFill>
-                          <a:latin typeface="Courier New" pitchFamily="34" charset="0"/>
-                          <a:ea typeface="Courier New" pitchFamily="34" charset="-122"/>
-                          <a:cs typeface="Courier New" pitchFamily="34" charset="-120"/>
-                        </a:rPr>
-                        <a:t>init (remove_action)</a:t>
-                      </a:r>
-                      <a:endParaRPr lang="en-US" sz="1100" dirty="0">
-                        <a:latin typeface="Courier New" charset="0"/>
-                        <a:ea typeface="Courier New" charset="0"/>
-                        <a:cs typeface="Courier New" charset="0"/>
-                      </a:endParaRPr>
-                    </a:p>
-                  </a:txBody>
-                  <a:tcPr marL="50800" marR="50800" marT="50800" marB="50800" anchor="ctr">
-                    <a:lnL w="12700" cap="flat" cmpd="sng" algn="ctr">
-                      <a:solidFill>
-                        <a:srgbClr val="DCE6EB"/>
-                      </a:solidFill>
-                      <a:prstDash val="solid"/>
-                      <a:round/>
-                      <a:headEnd type="none" w="med" len="med"/>
-                      <a:tailEnd type="none" w="med" len="med"/>
-                    </a:lnL>
-                    <a:lnR w="12700" cap="flat" cmpd="sng" algn="ctr">
-                      <a:solidFill>
-                        <a:srgbClr val="DCE6EB"/>
-                      </a:solidFill>
-                      <a:prstDash val="solid"/>
-                      <a:round/>
-                      <a:headEnd type="none" w="med" len="med"/>
-                      <a:tailEnd type="none" w="med" len="med"/>
-                    </a:lnR>
-                    <a:lnT w="12700" cap="flat" cmpd="sng" algn="ctr">
-                      <a:solidFill>
-                        <a:srgbClr val="DCE6EB"/>
-                      </a:solidFill>
-                      <a:prstDash val="solid"/>
-                      <a:round/>
-                      <a:headEnd type="none" w="med" len="med"/>
-                      <a:tailEnd type="none" w="med" len="med"/>
-                    </a:lnT>
-                    <a:lnB w="12700" cap="flat" cmpd="sng" algn="ctr">
-                      <a:solidFill>
-                        <a:srgbClr val="DCE6EB"/>
-                      </a:solidFill>
-                      <a:prstDash val="solid"/>
-                      <a:round/>
-                      <a:headEnd type="none" w="med" len="med"/>
-                      <a:tailEnd type="none" w="med" len="med"/>
-                    </a:lnB>
-                    <a:solidFill>
-                      <a:srgbClr val="EAF1F5"/>
-                    </a:solidFill>
-                  </a:tcPr>
-                </a:tc>
-                <a:tc>
-                  <a:txBody>
-                    <a:bodyPr/>
-                    <a:lstStyle/>
-                    <a:p>
-                      <a:pPr algn="l" indent="0" marL="0">
-                        <a:buNone/>
-                      </a:pPr>
-                      <a:r>
-                        <a:rPr lang="en-US" sz="1200" dirty="0">
-                          <a:solidFill>
-                            <a:srgbClr val="4A5A63"/>
-                          </a:solidFill>
-                          <a:latin typeface="Calibri" pitchFamily="34" charset="0"/>
-                          <a:ea typeface="Calibri" pitchFamily="34" charset="-122"/>
-                          <a:cs typeface="Calibri" pitchFamily="34" charset="-120"/>
-                        </a:rPr>
                         <a:t>Performance</a:t>
-                      </a:r>
-                      <a:endParaRPr lang="en-US" sz="1200" dirty="0">
-                        <a:latin typeface="Calibri" charset="0"/>
-                        <a:ea typeface="Calibri" charset="0"/>
-                        <a:cs typeface="Calibri" charset="0"/>
-                      </a:endParaRPr>
-                    </a:p>
-                  </a:txBody>
-                  <a:tcPr marL="50800" marR="50800" marT="50800" marB="50800" anchor="ctr">
-                    <a:lnL w="12700" cap="flat" cmpd="sng" algn="ctr">
-                      <a:solidFill>
-                        <a:srgbClr val="DCE6EB"/>
-                      </a:solidFill>
-                      <a:prstDash val="solid"/>
-                      <a:round/>
-                      <a:headEnd type="none" w="med" len="med"/>
-                      <a:tailEnd type="none" w="med" len="med"/>
-                    </a:lnL>
-                    <a:lnR w="12700" cap="flat" cmpd="sng" algn="ctr">
-                      <a:solidFill>
-                        <a:srgbClr val="DCE6EB"/>
-                      </a:solidFill>
-                      <a:prstDash val="solid"/>
-                      <a:round/>
-                      <a:headEnd type="none" w="med" len="med"/>
-                      <a:tailEnd type="none" w="med" len="med"/>
-                    </a:lnR>
-                    <a:lnT w="12700" cap="flat" cmpd="sng" algn="ctr">
-                      <a:solidFill>
-                        <a:srgbClr val="DCE6EB"/>
-                      </a:solidFill>
-                      <a:prstDash val="solid"/>
-                      <a:round/>
-                      <a:headEnd type="none" w="med" len="med"/>
-                      <a:tailEnd type="none" w="med" len="med"/>
-                    </a:lnT>
-                    <a:lnB w="12700" cap="flat" cmpd="sng" algn="ctr">
-                      <a:solidFill>
-                        <a:srgbClr val="DCE6EB"/>
-                      </a:solidFill>
-                      <a:prstDash val="solid"/>
-                      <a:round/>
-                      <a:headEnd type="none" w="med" len="med"/>
-                      <a:tailEnd type="none" w="med" len="med"/>
-                    </a:lnB>
-                    <a:solidFill>
-                      <a:srgbClr val="EAF1F5"/>
-                    </a:solidFill>
-                  </a:tcPr>
-                </a:tc>
-              </a:tr>
-              <a:tr h="402336">
-                <a:tc>
-                  <a:txBody>
-                    <a:bodyPr/>
-                    <a:lstStyle/>
-                    <a:p>
-                      <a:pPr algn="l" indent="0" marL="0">
-                        <a:buNone/>
-                      </a:pPr>
-                      <a:r>
-                        <a:rPr lang="en-US" sz="1250" dirty="0">
-                          <a:solidFill>
-                            <a:srgbClr val="0F2733"/>
-                          </a:solidFill>
-                          <a:latin typeface="Calibri" pitchFamily="34" charset="0"/>
-                          <a:ea typeface="Calibri" pitchFamily="34" charset="-122"/>
-                          <a:cs typeface="Calibri" pitchFamily="34" charset="-120"/>
-                        </a:rPr>
-                        <a:t>Own the login logo + link</a:t>
-                      </a:r>
-                      <a:endParaRPr lang="en-US" sz="1250" dirty="0">
-                        <a:latin typeface="Calibri" charset="0"/>
-                        <a:ea typeface="Calibri" charset="0"/>
-                        <a:cs typeface="Calibri" charset="0"/>
-                      </a:endParaRPr>
-                    </a:p>
-                  </a:txBody>
-                  <a:tcPr marL="50800" marR="50800" marT="50800" marB="50800" anchor="ctr">
-                    <a:lnL w="12700" cap="flat" cmpd="sng" algn="ctr">
-                      <a:solidFill>
-                        <a:srgbClr val="DCE6EB"/>
-                      </a:solidFill>
-                      <a:prstDash val="solid"/>
-                      <a:round/>
-                      <a:headEnd type="none" w="med" len="med"/>
-                      <a:tailEnd type="none" w="med" len="med"/>
-                    </a:lnL>
-                    <a:lnR w="12700" cap="flat" cmpd="sng" algn="ctr">
-                      <a:solidFill>
-                        <a:srgbClr val="DCE6EB"/>
-                      </a:solidFill>
-                      <a:prstDash val="solid"/>
-                      <a:round/>
-                      <a:headEnd type="none" w="med" len="med"/>
-                      <a:tailEnd type="none" w="med" len="med"/>
-                    </a:lnR>
-                    <a:lnT w="12700" cap="flat" cmpd="sng" algn="ctr">
-                      <a:solidFill>
-                        <a:srgbClr val="DCE6EB"/>
-                      </a:solidFill>
-                      <a:prstDash val="solid"/>
-                      <a:round/>
-                      <a:headEnd type="none" w="med" len="med"/>
-                      <a:tailEnd type="none" w="med" len="med"/>
-                    </a:lnT>
-                    <a:lnB w="12700" cap="flat" cmpd="sng" algn="ctr">
-                      <a:solidFill>
-                        <a:srgbClr val="DCE6EB"/>
-                      </a:solidFill>
-                      <a:prstDash val="solid"/>
-                      <a:round/>
-                      <a:headEnd type="none" w="med" len="med"/>
-                      <a:tailEnd type="none" w="med" len="med"/>
-                    </a:lnB>
-                    <a:solidFill>
-                      <a:srgbClr val="FFFFFF"/>
-                    </a:solidFill>
-                  </a:tcPr>
-                </a:tc>
-                <a:tc>
-                  <a:txBody>
-                    <a:bodyPr/>
-                    <a:lstStyle/>
-                    <a:p>
-                      <a:pPr algn="l" indent="0" marL="0">
-                        <a:buNone/>
-                      </a:pPr>
-                      <a:r>
-                        <a:rPr lang="en-US" sz="1100" dirty="0">
-                          <a:solidFill>
-                            <a:srgbClr val="27607A"/>
-                          </a:solidFill>
-                          <a:latin typeface="Courier New" pitchFamily="34" charset="0"/>
-                          <a:ea typeface="Courier New" pitchFamily="34" charset="-122"/>
-                          <a:cs typeface="Courier New" pitchFamily="34" charset="-120"/>
-                        </a:rPr>
-                        <a:t>login_head / login_headerurl</a:t>
-                      </a:r>
-                      <a:endParaRPr lang="en-US" sz="1100" dirty="0">
-                        <a:latin typeface="Courier New" charset="0"/>
-                        <a:ea typeface="Courier New" charset="0"/>
-                        <a:cs typeface="Courier New" charset="0"/>
-                      </a:endParaRPr>
-                    </a:p>
-                  </a:txBody>
-                  <a:tcPr marL="50800" marR="50800" marT="50800" marB="50800" anchor="ctr">
-                    <a:lnL w="12700" cap="flat" cmpd="sng" algn="ctr">
-                      <a:solidFill>
-                        <a:srgbClr val="DCE6EB"/>
-                      </a:solidFill>
-                      <a:prstDash val="solid"/>
-                      <a:round/>
-                      <a:headEnd type="none" w="med" len="med"/>
-                      <a:tailEnd type="none" w="med" len="med"/>
-                    </a:lnL>
-                    <a:lnR w="12700" cap="flat" cmpd="sng" algn="ctr">
-                      <a:solidFill>
-                        <a:srgbClr val="DCE6EB"/>
-                      </a:solidFill>
-                      <a:prstDash val="solid"/>
-                      <a:round/>
-                      <a:headEnd type="none" w="med" len="med"/>
-                      <a:tailEnd type="none" w="med" len="med"/>
-                    </a:lnR>
-                    <a:lnT w="12700" cap="flat" cmpd="sng" algn="ctr">
-                      <a:solidFill>
-                        <a:srgbClr val="DCE6EB"/>
-                      </a:solidFill>
-                      <a:prstDash val="solid"/>
-                      <a:round/>
-                      <a:headEnd type="none" w="med" len="med"/>
-                      <a:tailEnd type="none" w="med" len="med"/>
-                    </a:lnT>
-                    <a:lnB w="12700" cap="flat" cmpd="sng" algn="ctr">
-                      <a:solidFill>
-                        <a:srgbClr val="DCE6EB"/>
-                      </a:solidFill>
-                      <a:prstDash val="solid"/>
-                      <a:round/>
-                      <a:headEnd type="none" w="med" len="med"/>
-                      <a:tailEnd type="none" w="med" len="med"/>
-                    </a:lnB>
-                    <a:solidFill>
-                      <a:srgbClr val="FFFFFF"/>
-                    </a:solidFill>
-                  </a:tcPr>
-                </a:tc>
-                <a:tc>
-                  <a:txBody>
-                    <a:bodyPr/>
-                    <a:lstStyle/>
-                    <a:p>
-                      <a:pPr algn="l" indent="0" marL="0">
-                        <a:buNone/>
-                      </a:pPr>
-                      <a:r>
-                        <a:rPr lang="en-US" sz="1200" dirty="0">
-                          <a:solidFill>
-                            <a:srgbClr val="4A5A63"/>
-                          </a:solidFill>
-                          <a:latin typeface="Calibri" pitchFamily="34" charset="0"/>
-                          <a:ea typeface="Calibri" pitchFamily="34" charset="-122"/>
-                          <a:cs typeface="Calibri" pitchFamily="34" charset="-120"/>
-                        </a:rPr>
-                        <a:t>Branding</a:t>
                       </a:r>
                       <a:endParaRPr lang="en-US" sz="1200" dirty="0">
                         <a:latin typeface="Calibri" charset="0"/>
@@ -17117,7 +16725,7 @@
                 <a:ea typeface="Courier New" pitchFamily="34" charset="-122"/>
                 <a:cs typeface="Courier New" pitchFamily="34" charset="-120"/>
               </a:rPr>
-              <a:t>if ( wpyeg_defaults_enabled( 'disable_xmlrpc' ) ) {</a:t>
+              <a:t>if ( wpyeg_defaults_enabled( 'restrict_rest_user_discovery' ) ) {</a:t>
             </a:r>
             <a:endParaRPr lang="en-US" sz="1500" dirty="0"/>
           </a:p>
@@ -17137,7 +16745,7 @@
                 <a:ea typeface="Courier New" pitchFamily="34" charset="-122"/>
                 <a:cs typeface="Courier New" pitchFamily="34" charset="-120"/>
               </a:rPr>
-              <a:t>    add_filter( 'xmlrpc_enabled', '__return_false' );</a:t>
+              <a:t>    add_filter( 'rest_endpoints', $hide_users_endpoint );</a:t>
             </a:r>
             <a:endParaRPr lang="en-US" sz="1500" dirty="0"/>
           </a:p>
@@ -19979,7 +19587,7 @@
                 <a:ea typeface="Cambria" pitchFamily="34" charset="-122"/>
                 <a:cs typeface="Cambria" pitchFamily="34" charset="-120"/>
               </a:rPr>
-              <a:t>Disable XML-RPC</a:t>
+              <a:t>Lock XML-RPC down by category</a:t>
             </a:r>
             <a:endParaRPr lang="en-US" sz="3000" dirty="0"/>
           </a:p>
@@ -20021,7 +19629,7 @@
                 <a:ea typeface="Calibri" pitchFamily="34" charset="-122"/>
                 <a:cs typeface="Calibri" pitchFamily="34" charset="-120"/>
               </a:rPr>
-              <a:t>xmlrpc.php is a classic amplifier: one request can attempt hundreds of logins, and its pingback method has been used to bounce DDoS traffic. Unless you rely on the legacy mobile app or some Jetpack paths, switch it off.</a:t>
+              <a:t>Not all-or-nothing. Pingbacks (spam/DDoS) and the credential-authenticated blogging APIs (the brute-force target) come off via a method filter; system.multicall can't be filtered off, so a replacement server refuses it. Jetpack's jetpack.* methods are left untouched.</a:t>
             </a:r>
             <a:endParaRPr lang="en-US" sz="1600" dirty="0"/>
           </a:p>
@@ -20107,7 +19715,7 @@
                 <a:ea typeface="Courier New" pitchFamily="34" charset="-122"/>
                 <a:cs typeface="Courier New" pitchFamily="34" charset="-120"/>
               </a:rPr>
-              <a:t>wpyeg_disable_xmlrpc</a:t>
+              <a:t>wpyeg_xmlrpc_allow_pingbacks / _remote_publishing / _multicall</a:t>
             </a:r>
             <a:pPr indent="0" marL="0">
               <a:lnSpc>
@@ -20147,13 +19755,13 @@
             <a:r>
               <a:rPr lang="en-US" sz="1150" b="1" dirty="0">
                 <a:solidFill>
-                  <a:srgbClr val="27607A"/>
+                  <a:srgbClr val="C88F33"/>
                 </a:solidFill>
                 <a:latin typeface="Courier New" pitchFamily="34" charset="0"/>
                 <a:ea typeface="Courier New" pitchFamily="34" charset="-122"/>
                 <a:cs typeface="Courier New" pitchFamily="34" charset="-120"/>
               </a:rPr>
-              <a:t>yes</a:t>
+              <a:t>no (each)</a:t>
             </a:r>
             <a:endParaRPr lang="en-US" sz="1150" dirty="0"/>
           </a:p>
@@ -20223,13 +19831,13 @@
             <a:r>
               <a:rPr lang="en-US" sz="1150" dirty="0">
                 <a:solidFill>
-                  <a:srgbClr val="DCEAF1"/>
+                  <a:srgbClr val="8FBF9F"/>
                 </a:solidFill>
                 <a:latin typeface="Courier New" pitchFamily="34" charset="0"/>
                 <a:ea typeface="Courier New" pitchFamily="34" charset="-122"/>
                 <a:cs typeface="Courier New" pitchFamily="34" charset="-120"/>
               </a:rPr>
-              <a:t>add_filter( 'xmlrpc_enabled',</a:t>
+              <a:t>// each category off → remove its methods</a:t>
             </a:r>
             <a:endParaRPr lang="en-US" sz="1150" dirty="0"/>
           </a:p>
@@ -20243,13 +19851,13 @@
             <a:r>
               <a:rPr lang="en-US" sz="1150" dirty="0">
                 <a:solidFill>
-                  <a:srgbClr val="E7C070"/>
+                  <a:srgbClr val="DCEAF1"/>
                 </a:solidFill>
                 <a:latin typeface="Courier New" pitchFamily="34" charset="0"/>
                 <a:ea typeface="Courier New" pitchFamily="34" charset="-122"/>
                 <a:cs typeface="Courier New" pitchFamily="34" charset="-120"/>
               </a:rPr>
-              <a:t>            '__return_false' );</a:t>
+              <a:t>add_filter( 'xmlrpc_methods', function ( $m ) {</a:t>
             </a:r>
             <a:endParaRPr lang="en-US" sz="1150" dirty="0"/>
           </a:p>
@@ -20269,7 +19877,7 @@
                 <a:ea typeface="Courier New" pitchFamily="34" charset="-122"/>
                 <a:cs typeface="Courier New" pitchFamily="34" charset="-120"/>
               </a:rPr>
-              <a:t> </a:t>
+              <a:t>  if ( ! allow( 'pingbacks' ) )</a:t>
             </a:r>
             <a:endParaRPr lang="en-US" sz="1150" dirty="0"/>
           </a:p>
@@ -20283,13 +19891,13 @@
             <a:r>
               <a:rPr lang="en-US" sz="1150" dirty="0">
                 <a:solidFill>
-                  <a:srgbClr val="8FBF9F"/>
+                  <a:srgbClr val="E7C070"/>
                 </a:solidFill>
                 <a:latin typeface="Courier New" pitchFamily="34" charset="0"/>
                 <a:ea typeface="Courier New" pitchFamily="34" charset="-122"/>
                 <a:cs typeface="Courier New" pitchFamily="34" charset="-120"/>
               </a:rPr>
-              <a:t>// stop bots probing the discovery header</a:t>
+              <a:t>    unset( $m['pingback.ping'] );</a:t>
             </a:r>
             <a:endParaRPr lang="en-US" sz="1150" dirty="0"/>
           </a:p>
@@ -20309,7 +19917,7 @@
                 <a:ea typeface="Courier New" pitchFamily="34" charset="-122"/>
                 <a:cs typeface="Courier New" pitchFamily="34" charset="-120"/>
               </a:rPr>
-              <a:t>add_filter( 'wp_headers', function ( $h ) {</a:t>
+              <a:t>  if ( ! allow( 'remote_publishing' ) )</a:t>
             </a:r>
             <a:endParaRPr lang="en-US" sz="1150" dirty="0"/>
           </a:p>
@@ -20323,13 +19931,13 @@
             <a:r>
               <a:rPr lang="en-US" sz="1150" dirty="0">
                 <a:solidFill>
-                  <a:srgbClr val="E7C070"/>
+                  <a:srgbClr val="8FBF9F"/>
                 </a:solidFill>
                 <a:latin typeface="Courier New" pitchFamily="34" charset="0"/>
                 <a:ea typeface="Courier New" pitchFamily="34" charset="-122"/>
                 <a:cs typeface="Courier New" pitchFamily="34" charset="-120"/>
               </a:rPr>
-              <a:t>    unset( $h['X-Pingback'] );</a:t>
+              <a:t>    // drop wp.* metaWeblog.* mt.* blogger.*</a:t>
             </a:r>
             <a:endParaRPr lang="en-US" sz="1150" dirty="0"/>
           </a:p>
@@ -20349,7 +19957,7 @@
                 <a:ea typeface="Courier New" pitchFamily="34" charset="-122"/>
                 <a:cs typeface="Courier New" pitchFamily="34" charset="-120"/>
               </a:rPr>
-              <a:t>    return $h;</a:t>
+              <a:t>  return $m;</a:t>
             </a:r>
             <a:endParaRPr lang="en-US" sz="1150" dirty="0"/>
           </a:p>
@@ -20383,13 +19991,33 @@
             <a:r>
               <a:rPr lang="en-US" sz="1150" dirty="0">
                 <a:solidFill>
-                  <a:srgbClr val="DCEAF1"/>
+                  <a:srgbClr val="8FBF9F"/>
                 </a:solidFill>
                 <a:latin typeface="Courier New" pitchFamily="34" charset="0"/>
                 <a:ea typeface="Courier New" pitchFamily="34" charset="-122"/>
                 <a:cs typeface="Courier New" pitchFamily="34" charset="-120"/>
               </a:rPr>
-              <a:t>remove_action( 'wp_head', 'rsd_link' );</a:t>
+              <a:t>// multicall: swap in a server that refuses it</a:t>
+            </a:r>
+            <a:endParaRPr lang="en-US" sz="1150" dirty="0"/>
+          </a:p>
+          <a:p>
+            <a:pPr algn="l" indent="0" marL="0">
+              <a:lnSpc>
+                <a:spcPct val="108000"/>
+              </a:lnSpc>
+              <a:buNone/>
+            </a:pPr>
+            <a:r>
+              <a:rPr lang="en-US" sz="1150" dirty="0">
+                <a:solidFill>
+                  <a:srgbClr val="E7C070"/>
+                </a:solidFill>
+                <a:latin typeface="Courier New" pitchFamily="34" charset="0"/>
+                <a:ea typeface="Courier New" pitchFamily="34" charset="-122"/>
+                <a:cs typeface="Courier New" pitchFamily="34" charset="-120"/>
+              </a:rPr>
+              <a:t>add_filter( 'wp_xmlrpc_server_class', $refuse );</a:t>
             </a:r>
             <a:endParaRPr lang="en-US" sz="1150" dirty="0"/>
           </a:p>
@@ -20591,7 +20219,7 @@
                 <a:ea typeface="Cambria" pitchFamily="34" charset="-122"/>
                 <a:cs typeface="Cambria" pitchFamily="34" charset="-120"/>
               </a:rPr>
-              <a:t>Disable Application Passwords</a:t>
+              <a:t>Keep Application Passwords available</a:t>
             </a:r>
             <a:endParaRPr lang="en-US" sz="3000" dirty="0"/>
           </a:p>
@@ -20633,7 +20261,7 @@
                 <a:ea typeface="Calibri" pitchFamily="34" charset="-122"/>
                 <a:cs typeface="Calibri" pitchFamily="34" charset="-120"/>
               </a:rPr>
-              <a:t>Application Passwords mint long-lived credentials for the REST API. Great for headless setups — but if nobody's using them, they're just a secret waiting to leak. No feature, nothing to steal.</a:t>
+              <a:t>The one we don't lock down. Application Passwords are hashed, per-application, and individually revocable — the safer REST credential, and the only one core accepts for REST Basic Auth. So they stay on; prohibit them only if policy forbids non-interactive credentials.</a:t>
             </a:r>
             <a:endParaRPr lang="en-US" sz="1600" dirty="0"/>
           </a:p>
@@ -20759,13 +20387,13 @@
             <a:r>
               <a:rPr lang="en-US" sz="1150" b="1" dirty="0">
                 <a:solidFill>
-                  <a:srgbClr val="27607A"/>
+                  <a:srgbClr val="C88F33"/>
                 </a:solidFill>
                 <a:latin typeface="Courier New" pitchFamily="34" charset="0"/>
                 <a:ea typeface="Courier New" pitchFamily="34" charset="-122"/>
                 <a:cs typeface="Courier New" pitchFamily="34" charset="-120"/>
               </a:rPr>
-              <a:t>yes</a:t>
+              <a:t>no (available)</a:t>
             </a:r>
             <a:endParaRPr lang="en-US" sz="1150" dirty="0"/>
           </a:p>
@@ -20835,13 +20463,13 @@
             <a:r>
               <a:rPr lang="en-US" sz="1250" dirty="0">
                 <a:solidFill>
-                  <a:srgbClr val="DCEAF1"/>
+                  <a:srgbClr val="8FBF9F"/>
                 </a:solidFill>
                 <a:latin typeface="Courier New" pitchFamily="34" charset="0"/>
                 <a:ea typeface="Courier New" pitchFamily="34" charset="-122"/>
                 <a:cs typeface="Courier New" pitchFamily="34" charset="-120"/>
               </a:rPr>
-              <a:t>add_filter(</a:t>
+              <a:t>// available by default —</a:t>
             </a:r>
             <a:endParaRPr lang="en-US" sz="1250" dirty="0"/>
           </a:p>
@@ -20855,13 +20483,13 @@
             <a:r>
               <a:rPr lang="en-US" sz="1250" dirty="0">
                 <a:solidFill>
-                  <a:srgbClr val="E7C070"/>
+                  <a:srgbClr val="8FBF9F"/>
                 </a:solidFill>
                 <a:latin typeface="Courier New" pitchFamily="34" charset="0"/>
                 <a:ea typeface="Courier New" pitchFamily="34" charset="-122"/>
                 <a:cs typeface="Courier New" pitchFamily="34" charset="-120"/>
               </a:rPr>
-              <a:t>  'wp_is_application_passwords_available',</a:t>
+              <a:t>// prohibit only if opted in</a:t>
             </a:r>
             <a:endParaRPr lang="en-US" sz="1250" dirty="0"/>
           </a:p>
@@ -20875,13 +20503,13 @@
             <a:r>
               <a:rPr lang="en-US" sz="1250" dirty="0">
                 <a:solidFill>
-                  <a:srgbClr val="E7C070"/>
+                  <a:srgbClr val="DCEAF1"/>
                 </a:solidFill>
                 <a:latin typeface="Courier New" pitchFamily="34" charset="0"/>
                 <a:ea typeface="Courier New" pitchFamily="34" charset="-122"/>
                 <a:cs typeface="Courier New" pitchFamily="34" charset="-120"/>
               </a:rPr>
-              <a:t>  '__return_false'</a:t>
+              <a:t>if ( wpyeg_defaults_enabled(</a:t>
             </a:r>
             <a:endParaRPr lang="en-US" sz="1250" dirty="0"/>
           </a:p>
@@ -20901,7 +20529,7 @@
                 <a:ea typeface="Courier New" pitchFamily="34" charset="-122"/>
                 <a:cs typeface="Courier New" pitchFamily="34" charset="-120"/>
               </a:rPr>
-              <a:t>);</a:t>
+              <a:t>       'disable_application_passwords' ) ) {</a:t>
             </a:r>
             <a:endParaRPr lang="en-US" sz="1250" dirty="0"/>
           </a:p>
@@ -20921,7 +20549,7 @@
                 <a:ea typeface="Courier New" pitchFamily="34" charset="-122"/>
                 <a:cs typeface="Courier New" pitchFamily="34" charset="-120"/>
               </a:rPr>
-              <a:t> </a:t>
+              <a:t>  add_filter(</a:t>
             </a:r>
             <a:endParaRPr lang="en-US" sz="1250" dirty="0"/>
           </a:p>
@@ -20935,13 +20563,13 @@
             <a:r>
               <a:rPr lang="en-US" sz="1250" dirty="0">
                 <a:solidFill>
-                  <a:srgbClr val="8FBF9F"/>
+                  <a:srgbClr val="E7C070"/>
                 </a:solidFill>
                 <a:latin typeface="Courier New" pitchFamily="34" charset="0"/>
                 <a:ea typeface="Courier New" pitchFamily="34" charset="-122"/>
                 <a:cs typeface="Courier New" pitchFamily="34" charset="-120"/>
               </a:rPr>
-              <a:t>// Turn this OFF again if you run a</a:t>
+              <a:t>    'wp_is_application_passwords_available',</a:t>
             </a:r>
             <a:endParaRPr lang="en-US" sz="1250" dirty="0"/>
           </a:p>
@@ -20955,13 +20583,53 @@
             <a:r>
               <a:rPr lang="en-US" sz="1250" dirty="0">
                 <a:solidFill>
-                  <a:srgbClr val="8FBF9F"/>
+                  <a:srgbClr val="E7C070"/>
                 </a:solidFill>
                 <a:latin typeface="Courier New" pitchFamily="34" charset="0"/>
                 <a:ea typeface="Courier New" pitchFamily="34" charset="-122"/>
                 <a:cs typeface="Courier New" pitchFamily="34" charset="-120"/>
               </a:rPr>
-              <a:t>// headless / external integration.</a:t>
+              <a:t>    '__return_false'</a:t>
+            </a:r>
+            <a:endParaRPr lang="en-US" sz="1250" dirty="0"/>
+          </a:p>
+          <a:p>
+            <a:pPr algn="l" indent="0" marL="0">
+              <a:lnSpc>
+                <a:spcPct val="108000"/>
+              </a:lnSpc>
+              <a:buNone/>
+            </a:pPr>
+            <a:r>
+              <a:rPr lang="en-US" sz="1250" dirty="0">
+                <a:solidFill>
+                  <a:srgbClr val="DCEAF1"/>
+                </a:solidFill>
+                <a:latin typeface="Courier New" pitchFamily="34" charset="0"/>
+                <a:ea typeface="Courier New" pitchFamily="34" charset="-122"/>
+                <a:cs typeface="Courier New" pitchFamily="34" charset="-120"/>
+              </a:rPr>
+              <a:t>  );</a:t>
+            </a:r>
+            <a:endParaRPr lang="en-US" sz="1250" dirty="0"/>
+          </a:p>
+          <a:p>
+            <a:pPr algn="l" indent="0" marL="0">
+              <a:lnSpc>
+                <a:spcPct val="108000"/>
+              </a:lnSpc>
+              <a:buNone/>
+            </a:pPr>
+            <a:r>
+              <a:rPr lang="en-US" sz="1250" dirty="0">
+                <a:solidFill>
+                  <a:srgbClr val="DCEAF1"/>
+                </a:solidFill>
+                <a:latin typeface="Courier New" pitchFamily="34" charset="0"/>
+                <a:ea typeface="Courier New" pitchFamily="34" charset="-122"/>
+                <a:cs typeface="Courier New" pitchFamily="34" charset="-120"/>
+              </a:rPr>
+              <a:t>}</a:t>
             </a:r>
             <a:endParaRPr lang="en-US" sz="1250" dirty="0"/>
           </a:p>

</xml_diff>

<commit_message>
docs(workshop): prose & voice polish (Fable pass)
Editorial pass on the deck's narration and speaker notes for voice
consistency and teaching clarity — no technical changes. The recently
rewritten security slides now match the maintainer's analogy-driven
register:

- XML-RPC: an old switchboard where every method is a line — unplug lines,
  don't rip the box off the wall; system.multicall is the stubborn one IXR
  re-adds, so a replacement server refuses it.
- Application Passwords: a spare key cut for one app — hashed, per-app,
  revocable, no lock-change needed.
- admin search: reading the whole library vs. checking the spines.
- login logo: the welcome mat links to someone else's house.

Verified: no option names, defaults, code lines, or technical claims
changed, and the Jetpack/multicall hedging is preserved (jetpack.* left
untouched → don't block the endpoint; no multicall-safety overclaim). pptx
regenerated. The PDF still needs an iA Presenter re-export.
</commit_message>
<xml_diff>
--- a/workshop/Better-by-Default.pptx
+++ b/workshop/Better-by-Default.pptx
@@ -1321,7 +1321,7 @@
           <a:p>
             <a:r>
               <a:rPr lang="en-US" dirty="0"/>
-              <a:t>post_search_columns (WP 6.2+) narrows the columns instead of rewriting the SQL clause — it keeps core's term parsing and the logged-out password guard intact. Scoping filters correctly is the craft here.</a:t>
+              <a:t>post_search_columns (WP 6.2+) narrows the columns instead of rewriting the SQL clause — core's term parsing and the logged-out password guard stay intact. Scope the filter; don't bulldoze the query. That's the craft here.</a:t>
             </a:r>
             <a:endParaRPr lang="en-US" dirty="0"/>
           </a:p>
@@ -1497,7 +1497,7 @@
           <a:p>
             <a:r>
               <a:rPr lang="en-US" dirty="0"/>
-              <a:t>These aren't hypothetical. Every one is a default you can flip. The rest of the talk is: which doors, and the one line of code that closes each.</a:t>
+              <a:t>These aren't hypothetical. Every one is a default you can flip. The rest of tonight is just: which doors, and the one line of code that closes each.</a:t>
             </a:r>
             <a:endParaRPr lang="en-US" dirty="0"/>
           </a:p>
@@ -1673,7 +1673,7 @@
           <a:p>
             <a:r>
               <a:rPr lang="en-US" dirty="0"/>
-              <a:t>Default is keep_default — leave the login screen untouched. Swap in a background-image to drop in the client's own logo. Tiny detail clients always notice.</a:t>
+              <a:t>Default is keep_default — leave the login screen untouched. Swap in a background-image to drop in the client's own logo. Tiny detail — clients always notice it.</a:t>
             </a:r>
             <a:endParaRPr lang="en-US" dirty="0"/>
           </a:p>
@@ -2817,7 +2817,7 @@
           <a:p>
             <a:r>
               <a:rPr lang="en-US" dirty="0"/>
-              <a:t>system.multicall can't be removed by the xmlrpc_methods filter — IXR re-adds it — so we swap in a server that refuses it. Don't *block the endpoint* on a Jetpack site: that breaks its WordPress.com connection; the method toggles leave jetpack.* alone.</a:t>
+              <a:t>system.multicall is the stubborn line: the xmlrpc_methods filter can't remove it — IXR plugs it right back in — so we swap in a server that refuses the call. And don't *block the endpoint* on a Jetpack site: that breaks its WordPress.com connection. The method toggles leave jetpack.* alone.</a:t>
             </a:r>
             <a:endParaRPr lang="en-US" dirty="0"/>
           </a:p>
@@ -2905,7 +2905,7 @@
           <a:p>
             <a:r>
               <a:rPr lang="en-US" dirty="0"/>
-              <a:t>Turning them off just pushes people to worse habits like sharing the login password. They stay available by default — the safer, revocable REST credential.</a:t>
+              <a:t>Switching them off doesn't stop people connecting things — it just pushes them to worse habits, like sharing the login password. So they stay available by default: the safer, revocable REST credential.</a:t>
             </a:r>
             <a:endParaRPr lang="en-US" dirty="0"/>
           </a:p>
@@ -3676,7 +3676,7 @@
                 <a:ea typeface="Calibri" pitchFamily="34" charset="-122"/>
                 <a:cs typeface="Calibri" pitchFamily="34" charset="-120"/>
               </a:rPr>
-              <a:t>NIST 800-63B and OWASP now say length plus breach screening beats composition rules. Forcing upper/lower/number/symbol just herds users to Password1! — predictable, not strong. We require 15+ chars and screen against known breaches, server-side.</a:t>
+              <a:t>The rules changed: NIST 800-63B and OWASP now say length plus breach screening beats composition rules. Forcing upper/lower/number/symbol just herds everyone to Password1! — predictable, not strong. We require 15+ chars and screen against known breaches, server-side.</a:t>
             </a:r>
             <a:endParaRPr lang="en-US" sz="1600" dirty="0"/>
           </a:p>
@@ -7858,7 +7858,7 @@
                 <a:ea typeface="Calibri" pitchFamily="34" charset="-122"/>
                 <a:cs typeface="Calibri" pitchFamily="34" charset="-120"/>
               </a:rPr>
-              <a:t>On big sites the admin list-table search scans post content and crawls. Title-only search is far faster (off by default — it changes editor expectations). And the floating front-end admin bar can be hidden for non-admins.</a:t>
+              <a:t>On big sites the admin list-table search reads every word of every post — and crawls. Title-only search checks just the spines, far faster (off by default — it changes editor expectations). And the floating front-end admin bar can be hidden for non-admins.</a:t>
             </a:r>
             <a:endParaRPr lang="en-US" sz="1600" dirty="0"/>
           </a:p>
@@ -10233,7 +10233,7 @@
                 <a:ea typeface="Calibri" pitchFamily="34" charset="-122"/>
                 <a:cs typeface="Calibri" pitchFamily="34" charset="-120"/>
               </a:rPr>
-              <a:t>The default WordPress “W” on wp-login.php links out to wordpress.org — a subtle trust leak. But changing the login screen out of the box is intrusive, so the default is to leave it alone; removing, unlinking, or replacing the logo is an opt-in, and any change points the link home.</a:t>
+              <a:t>The login page is the site's front door — and the default “W” on wp-login.php links out to wordpress.org, a subtle trust leak. But repainting a client's front door uninvited is rude, so the default is to leave it alone; removing, unlinking, or replacing the logo is an opt-in, and any change points the link home.</a:t>
             </a:r>
             <a:endParaRPr lang="en-US" sz="1600" dirty="0"/>
           </a:p>
@@ -19629,7 +19629,7 @@
                 <a:ea typeface="Calibri" pitchFamily="34" charset="-122"/>
                 <a:cs typeface="Calibri" pitchFamily="34" charset="-120"/>
               </a:rPr>
-              <a:t>Not all-or-nothing. Pingbacks (spam/DDoS) and the credential-authenticated blogging APIs (the brute-force target) come off via a method filter; system.multicall can't be filtered off, so a replacement server refuses it. Jetpack's jetpack.* methods are left untouched.</a:t>
+              <a:t>XML-RPC is an old switchboard — every method is a line. We unplug the lines we don't want: pingbacks (spam/DDoS) and the credential-authenticated blogging APIs (the brute-force target), via a method filter. system.multicall can't be filtered off, so a replacement server refuses it. Jetpack's jetpack.* lines stay untouched.</a:t>
             </a:r>
             <a:endParaRPr lang="en-US" sz="1600" dirty="0"/>
           </a:p>
@@ -20261,7 +20261,7 @@
                 <a:ea typeface="Calibri" pitchFamily="34" charset="-122"/>
                 <a:cs typeface="Calibri" pitchFamily="34" charset="-120"/>
               </a:rPr>
-              <a:t>The one we don't lock down. Application Passwords are hashed, per-application, and individually revocable — the safer REST credential, and the only one core accepts for REST Basic Auth. So they stay on; prohibit them only if policy forbids non-interactive credentials.</a:t>
+              <a:t>The one we don't lock down. An Application Password is a spare key cut for one app — hashed, per-application, revocable on its own. It's the safer REST credential, and the only one core accepts for REST Basic Auth. So they stay on; prohibit them only if policy forbids non-interactive credentials.</a:t>
             </a:r>
             <a:endParaRPr lang="en-US" sz="1600" dirty="0"/>
           </a:p>

</xml_diff>

<commit_message>
feat: add safer update defaults and refresh guidance
</commit_message>
<xml_diff>
--- a/workshop/Better-by-Default.pptx
+++ b/workshop/Better-by-Default.pptx
@@ -2209,7 +2209,7 @@
           <a:p>
             <a:r>
               <a:rPr lang="en-US" dirty="0"/>
-              <a:t>This is your screenshot slide — everything on-by-default in one view, mapped to the core hook. Three deliberate *non*-defaults worth calling out: Application Passwords stay AVAILABLE (the safer REST credential), the login logo is LEFT ALONE unless you opt in, and removing the version fingerprint is OFF, because it is obscurity rather than hardening. All three are choices, not oversights — and the last one is the honest test of the whole talk: if a default doesn't actually make the site safer, don't ship it as security.</a:t>
+              <a:t>This is your screenshot slide — everything on-by-default in one view, mapped to the core hook. Updates follow the same principle: maintenance/security core releases and translations install automatically; major core releases wait for testing; plugin and theme code keeps its per-item WordPress setting because version numbers do not reliably identify risk. Three deliberate non-defaults worth calling out: Application Passwords stay AVAILABLE, the login logo is LEFT ALONE, and removing the version fingerprint is OFF because it is obscurity rather than hardening.</a:t>
             </a:r>
             <a:endParaRPr lang="en-US" dirty="0"/>
           </a:p>
@@ -2913,12 +2913,12 @@
           <a:p>
             <a:r>
               <a:rPr lang="en-US" dirty="0"/>
-              <a:t>XML-RPC isn't one door — it's an old switchboard, and every method is a phone line. Rather than rip the box off the wall, we unplug lines by category. Four switches, all off by default:
-1. Pingbacks — drop pingback.ping, a spam and reflection-DDoS relay.
-2. Remote publishing — drop the credential-authenticated blogging methods (wp.*, metaWeblog.*, mt.*, blogger.*), the classic brute-force target. This also flips xmlrpc_enabled off and removes the RSD discovery link.
-3. system.multicall — the amplifier that batches thousands of login guesses into one request. You can't just unset it: IXR_Server::setCallbacks() re-adds it after the filter runs, so we swap in a replacement server that refuses it.
-4. Block the endpoint — the blunt hammer: xmlrpc.php returns 403 for everything.
-The first three are surgical — they leave third-party methods like Jetpack's jetpack.* connected, so the endpoint stays usable. The fourth nukes the lot, which breaks Jetpack; reach for it only if nothing on the site speaks XML-RPC.
+              <a:t>XML-RPC is a legitimate but aging API, not a backdoor or an emergency. It is an old switchboard where every method is a phone line. Rather than rip out a connection that Jetpack or a publishing client may need, we unplug unused lines by category. Four switches, all off by default:
+1. Pingbacks — drop pingback.ping, the clearest live nuisance and reflection-DDoS surface. A valid call performs database work, waits a second, and fetches the claimed source URL.
+2. Remote publishing — drop the credential-authenticated blogging methods (wp.*, metaWeblog.*, mt.*, blogger.*), another password-guessing entrance when legacy clients are not needed. This also flips xmlrpc_enabled off and removes the RSD discovery link.
+3. system.multicall — refuse a general batching wrapper with little established modern use. WordPress 4.4 stopped testing credentials after the first failed login in one XML-RPC request, so the old 'thousands of guesses' story is obsolete. Multicall can still batch other work, including pingbacks, but it does not enable pingback abuse.
+4. Block the endpoint — the blunt hammer: xmlrpc.php returns 403 for everything. Prefer doing this at the CDN, WAF, or web server so the request never consumes PHP.
+The first three are surgical and leave third-party registrations such as Jetpack's jetpack.* in place. That is not a compatibility guarantee: keep the endpoint reachable, leave Remote Publishing enabled until testing proves it unnecessary, and test the Jetpack connection and features after method changes. Block the endpoint only when nothing on the site speaks XML-RPC.
 [Aside — what's "IXR"? The Incutio XML-RPC library. Simon Willison released it in September 2002, one of his first open-source projects, while blogging from the University of Bath; both WordPress *and* Drupal adopted it, and it then sat largely untouched for 15+ years — long enough to pick up a CVE. Willison went on to co-create Django (2003–05 at the Lawrence Journal-World), build Lanyrd (sold to Eventbrite in 2013) and Datasette (2017), and is now one of the most-read writers on LLMs.]</a:t>
             </a:r>
             <a:endParaRPr lang="en-US" dirty="0"/>
@@ -9417,7 +9417,7 @@
                 <a:ea typeface="Cambria" pitchFamily="34" charset="-122"/>
                 <a:cs typeface="Cambria" pitchFamily="34" charset="-120"/>
               </a:rPr>
-              <a:t>Legacy XML-RPC wide open</a:t>
+              <a:t>Aging XML-RPC exposed</a:t>
             </a:r>
             <a:endParaRPr lang="en-US" sz="1900" dirty="0"/>
           </a:p>
@@ -9456,7 +9456,7 @@
                 <a:ea typeface="Calibri" pitchFamily="34" charset="-122"/>
                 <a:cs typeface="Calibri" pitchFamily="34" charset="-120"/>
               </a:rPr>
-              <a:t>Pingback and system.multicall amplifiers answer by default.</a:t>
+              <a:t>Unwanted pingbacks and unused methods add work and attack surface.</a:t>
             </a:r>
             <a:endParaRPr lang="en-US" sz="1400" dirty="0"/>
           </a:p>
@@ -16097,6 +16097,212 @@
                   </a:tcPr>
                 </a:tc>
               </a:tr>
+              <a:tr h="402336">
+                <a:tc>
+                  <a:txBody>
+                    <a:bodyPr/>
+                    <a:lstStyle/>
+                    <a:p>
+                      <a:pPr algn="l" indent="0" marL="0">
+                        <a:buNone/>
+                      </a:pPr>
+                      <a:r>
+                        <a:rPr lang="en-US" sz="1250" dirty="0">
+                          <a:solidFill>
+                            <a:srgbClr val="0F2733"/>
+                          </a:solidFill>
+                          <a:latin typeface="Calibri" pitchFamily="34" charset="0"/>
+                          <a:ea typeface="Calibri" pitchFamily="34" charset="-122"/>
+                          <a:cs typeface="Calibri" pitchFamily="34" charset="-120"/>
+                        </a:rPr>
+                        <a:t>Auto-update core security/maintenance + translations</a:t>
+                      </a:r>
+                      <a:endParaRPr lang="en-US" sz="1250" dirty="0">
+                        <a:latin typeface="Calibri" charset="0"/>
+                        <a:ea typeface="Calibri" charset="0"/>
+                        <a:cs typeface="Calibri" charset="0"/>
+                      </a:endParaRPr>
+                    </a:p>
+                  </a:txBody>
+                  <a:tcPr marL="50800" marR="50800" marT="50800" marB="50800" anchor="ctr">
+                    <a:lnL w="12700" cap="flat" cmpd="sng" algn="ctr">
+                      <a:solidFill>
+                        <a:srgbClr val="DCE6EB"/>
+                      </a:solidFill>
+                      <a:prstDash val="solid"/>
+                      <a:round/>
+                      <a:headEnd type="none" w="med" len="med"/>
+                      <a:tailEnd type="none" w="med" len="med"/>
+                    </a:lnL>
+                    <a:lnR w="12700" cap="flat" cmpd="sng" algn="ctr">
+                      <a:solidFill>
+                        <a:srgbClr val="DCE6EB"/>
+                      </a:solidFill>
+                      <a:prstDash val="solid"/>
+                      <a:round/>
+                      <a:headEnd type="none" w="med" len="med"/>
+                      <a:tailEnd type="none" w="med" len="med"/>
+                    </a:lnR>
+                    <a:lnT w="12700" cap="flat" cmpd="sng" algn="ctr">
+                      <a:solidFill>
+                        <a:srgbClr val="DCE6EB"/>
+                      </a:solidFill>
+                      <a:prstDash val="solid"/>
+                      <a:round/>
+                      <a:headEnd type="none" w="med" len="med"/>
+                      <a:tailEnd type="none" w="med" len="med"/>
+                    </a:lnT>
+                    <a:lnB w="12700" cap="flat" cmpd="sng" algn="ctr">
+                      <a:solidFill>
+                        <a:srgbClr val="DCE6EB"/>
+                      </a:solidFill>
+                      <a:prstDash val="solid"/>
+                      <a:round/>
+                      <a:headEnd type="none" w="med" len="med"/>
+                      <a:tailEnd type="none" w="med" len="med"/>
+                    </a:lnB>
+                    <a:solidFill>
+                      <a:srgbClr val="EAF1F5"/>
+                    </a:solidFill>
+                  </a:tcPr>
+                </a:tc>
+                <a:tc>
+                  <a:txBody>
+                    <a:bodyPr/>
+                    <a:lstStyle/>
+                    <a:p>
+                      <a:pPr algn="l" indent="0" marL="0">
+                        <a:buNone/>
+                      </a:pPr>
+                      <a:r>
+                        <a:rPr lang="en-US" sz="1100" dirty="0">
+                          <a:solidFill>
+                            <a:srgbClr val="27607A"/>
+                          </a:solidFill>
+                          <a:latin typeface="Courier New" pitchFamily="34" charset="0"/>
+                          <a:ea typeface="Courier New" pitchFamily="34" charset="-122"/>
+                          <a:cs typeface="Courier New" pitchFamily="34" charset="-120"/>
+                        </a:rPr>
+                        <a:t>allow_minor_auto_core_updates / auto_update_translation</a:t>
+                      </a:r>
+                      <a:endParaRPr lang="en-US" sz="1100" dirty="0">
+                        <a:latin typeface="Courier New" charset="0"/>
+                        <a:ea typeface="Courier New" charset="0"/>
+                        <a:cs typeface="Courier New" charset="0"/>
+                      </a:endParaRPr>
+                    </a:p>
+                  </a:txBody>
+                  <a:tcPr marL="50800" marR="50800" marT="50800" marB="50800" anchor="ctr">
+                    <a:lnL w="12700" cap="flat" cmpd="sng" algn="ctr">
+                      <a:solidFill>
+                        <a:srgbClr val="DCE6EB"/>
+                      </a:solidFill>
+                      <a:prstDash val="solid"/>
+                      <a:round/>
+                      <a:headEnd type="none" w="med" len="med"/>
+                      <a:tailEnd type="none" w="med" len="med"/>
+                    </a:lnL>
+                    <a:lnR w="12700" cap="flat" cmpd="sng" algn="ctr">
+                      <a:solidFill>
+                        <a:srgbClr val="DCE6EB"/>
+                      </a:solidFill>
+                      <a:prstDash val="solid"/>
+                      <a:round/>
+                      <a:headEnd type="none" w="med" len="med"/>
+                      <a:tailEnd type="none" w="med" len="med"/>
+                    </a:lnR>
+                    <a:lnT w="12700" cap="flat" cmpd="sng" algn="ctr">
+                      <a:solidFill>
+                        <a:srgbClr val="DCE6EB"/>
+                      </a:solidFill>
+                      <a:prstDash val="solid"/>
+                      <a:round/>
+                      <a:headEnd type="none" w="med" len="med"/>
+                      <a:tailEnd type="none" w="med" len="med"/>
+                    </a:lnT>
+                    <a:lnB w="12700" cap="flat" cmpd="sng" algn="ctr">
+                      <a:solidFill>
+                        <a:srgbClr val="DCE6EB"/>
+                      </a:solidFill>
+                      <a:prstDash val="solid"/>
+                      <a:round/>
+                      <a:headEnd type="none" w="med" len="med"/>
+                      <a:tailEnd type="none" w="med" len="med"/>
+                    </a:lnB>
+                    <a:solidFill>
+                      <a:srgbClr val="EAF1F5"/>
+                    </a:solidFill>
+                  </a:tcPr>
+                </a:tc>
+                <a:tc>
+                  <a:txBody>
+                    <a:bodyPr/>
+                    <a:lstStyle/>
+                    <a:p>
+                      <a:pPr algn="l" indent="0" marL="0">
+                        <a:buNone/>
+                      </a:pPr>
+                      <a:r>
+                        <a:rPr lang="en-US" sz="1200" dirty="0">
+                          <a:solidFill>
+                            <a:srgbClr val="4A5A63"/>
+                          </a:solidFill>
+                          <a:latin typeface="Calibri" pitchFamily="34" charset="0"/>
+                          <a:ea typeface="Calibri" pitchFamily="34" charset="-122"/>
+                          <a:cs typeface="Calibri" pitchFamily="34" charset="-120"/>
+                        </a:rPr>
+                        <a:t>Updates</a:t>
+                      </a:r>
+                      <a:endParaRPr lang="en-US" sz="1200" dirty="0">
+                        <a:latin typeface="Calibri" charset="0"/>
+                        <a:ea typeface="Calibri" charset="0"/>
+                        <a:cs typeface="Calibri" charset="0"/>
+                      </a:endParaRPr>
+                    </a:p>
+                  </a:txBody>
+                  <a:tcPr marL="50800" marR="50800" marT="50800" marB="50800" anchor="ctr">
+                    <a:lnL w="12700" cap="flat" cmpd="sng" algn="ctr">
+                      <a:solidFill>
+                        <a:srgbClr val="DCE6EB"/>
+                      </a:solidFill>
+                      <a:prstDash val="solid"/>
+                      <a:round/>
+                      <a:headEnd type="none" w="med" len="med"/>
+                      <a:tailEnd type="none" w="med" len="med"/>
+                    </a:lnL>
+                    <a:lnR w="12700" cap="flat" cmpd="sng" algn="ctr">
+                      <a:solidFill>
+                        <a:srgbClr val="DCE6EB"/>
+                      </a:solidFill>
+                      <a:prstDash val="solid"/>
+                      <a:round/>
+                      <a:headEnd type="none" w="med" len="med"/>
+                      <a:tailEnd type="none" w="med" len="med"/>
+                    </a:lnR>
+                    <a:lnT w="12700" cap="flat" cmpd="sng" algn="ctr">
+                      <a:solidFill>
+                        <a:srgbClr val="DCE6EB"/>
+                      </a:solidFill>
+                      <a:prstDash val="solid"/>
+                      <a:round/>
+                      <a:headEnd type="none" w="med" len="med"/>
+                      <a:tailEnd type="none" w="med" len="med"/>
+                    </a:lnT>
+                    <a:lnB w="12700" cap="flat" cmpd="sng" algn="ctr">
+                      <a:solidFill>
+                        <a:srgbClr val="DCE6EB"/>
+                      </a:solidFill>
+                      <a:prstDash val="solid"/>
+                      <a:round/>
+                      <a:headEnd type="none" w="med" len="med"/>
+                      <a:tailEnd type="none" w="med" len="med"/>
+                    </a:lnB>
+                    <a:solidFill>
+                      <a:srgbClr val="EAF1F5"/>
+                    </a:solidFill>
+                  </a:tcPr>
+                </a:tc>
+              </a:tr>
             </a:tbl>
           </a:graphicData>
         </a:graphic>
@@ -20275,7 +20481,7 @@
                 <a:ea typeface="Calibri" pitchFamily="34" charset="-122"/>
                 <a:cs typeface="Calibri" pitchFamily="34" charset="-120"/>
               </a:rPr>
-              <a:t>XML-RPC isn't one door — it's an old switchboard, and every method is a phone line. Rather than rip the box off the wall, we unplug lines by category. Four switches, all off by default.</a:t>
+              <a:t>XML-RPC is legitimate but aging — an extra surface, not a backdoor. We unplug unused method families while preserving the endpoint for integrations that need it.</a:t>
             </a:r>
             <a:endParaRPr lang="en-US" sz="1600" dirty="0"/>
           </a:p>

</xml_diff>

<commit_message>
docs: use Canadian spellings throughout
Prose across the README, reference doc, plugin readmes, and both
workshop decks now uses behaviour, defence, favour/favourite, honour,
and labelled.

Option keys and variables (wpyeg_login_logo_behavior,
wpyeg_frontend_admin_bar_behavior, $behavior) keep their existing
spelling — renaming them would break stored options and the settings
schema. "Meter" also stands: the password strength meter is a gauge,
not the unit of length. License headers and the composer license key
are parsed fields naming the GPL, so they are unchanged.

Rebuilt the derived artifacts: dist/sane-defaults.zip, the pptx, and
the PDF. The PDF was reconverted on macOS, so its monospace and
dingbat glyphs resolve to Courier New and ZapfDingbats rather than the
Liberation/DejaVu substitutes in the previous build.

Co-Authored-By: Claude Opus 5 <noreply@anthropic.com>
</commit_message>
<xml_diff>
--- a/workshop/Better-by-Default.pptx
+++ b/workshop/Better-by-Default.pptx
@@ -2297,7 +2297,7 @@
           <a:p>
             <a:r>
               <a:rPr lang="en-US" dirty="0"/>
-              <a:t>Hand out the zip and the reference doc. Invite everyone to add their own favorite default to the schema and share it back with the group.</a:t>
+              <a:t>Hand out the zip and the reference doc. Invite everyone to add their own favourite default to the schema and share it back with the group.</a:t>
             </a:r>
             <a:endParaRPr lang="en-US" dirty="0"/>
           </a:p>
@@ -2473,7 +2473,7 @@
           <a:p>
             <a:r>
               <a:rPr lang="en-US" dirty="0"/>
-              <a:t>WordPress is built to be interrupted at labeled moments (hooks) so you never edit core code. __return_false is a tiny built-in helper that just hands back false — perfect for switching a feature off.</a:t>
+              <a:t>WordPress is built to be interrupted at labelled moments (hooks) so you never edit core code. __return_false is a tiny built-in helper that just hands back false — perfect for switching a feature off.</a:t>
             </a:r>
             <a:endParaRPr lang="en-US" dirty="0"/>
           </a:p>
@@ -13729,7 +13729,7 @@
                 <a:ea typeface="Calibri" pitchFamily="34" charset="-122"/>
                 <a:cs typeface="Calibri" pitchFamily="34" charset="-120"/>
               </a:rPr>
-              <a:t>Flip a switch off, reload, watch the behavior change.</a:t>
+              <a:t>Flip a switch off, reload, watch the behaviour change.</a:t>
             </a:r>
             <a:endParaRPr lang="en-US" sz="1400" dirty="0"/>
           </a:p>
@@ -17095,7 +17095,7 @@
                 <a:ea typeface="Calibri" pitchFamily="34" charset="-122"/>
                 <a:cs typeface="Calibri" pitchFamily="34" charset="-120"/>
               </a:rPr>
-              <a:t>WordPress is built to be interrupted at labeled moments (hooks) so you never edit core code.</a:t>
+              <a:t>WordPress is built to be interrupted at labelled moments (hooks) so you never edit core code.</a:t>
             </a:r>
             <a:endParaRPr lang="en-US" sz="1600" dirty="0"/>
           </a:p>

</xml_diff>